<commit_message>
Upgrade: Regional grid-based electricity emission system and zone benchmarking
</commit_message>
<xml_diff>
--- a/EcoTrack_AI_With_OOP.pptx
+++ b/EcoTrack_AI_With_OOP.pptx
@@ -2813,7 +2813,7 @@
         </p:nvSpPr>
         <p:spPr>
           <a:xfrm>
-            <a:off x="2560320" y="457200"/>
+            <a:off x="2514600" y="424068"/>
             <a:ext cx="4114800" cy="4114800"/>
           </a:xfrm>
           <a:prstGeom prst="ellipse">
@@ -3059,6 +3059,111 @@
               <a:t>EcoTrack AI 🌿</a:t>
             </a:r>
             <a:endParaRPr lang="en-US" sz="900" dirty="0"/>
+          </a:p>
+        </p:txBody>
+      </p:sp>
+      <p:sp>
+        <p:nvSpPr>
+          <p:cNvPr id="7" name="TextBox 6"/>
+          <p:cNvSpPr txBox="1"/>
+          <p:nvPr/>
+        </p:nvSpPr>
+        <p:spPr>
+          <a:xfrm>
+            <a:off x="6394174" y="3498574"/>
+            <a:ext cx="2597426" cy="1477328"/>
+          </a:xfrm>
+          <a:prstGeom prst="rect">
+            <a:avLst/>
+          </a:prstGeom>
+          <a:solidFill>
+            <a:srgbClr val="0C2F19"/>
+          </a:solidFill>
+        </p:spPr>
+        <p:txBody>
+          <a:bodyPr wrap="square" rtlCol="0">
+            <a:spAutoFit/>
+          </a:bodyPr>
+          <a:lstStyle/>
+          <a:p>
+            <a:r>
+              <a:rPr lang="en-US" dirty="0" smtClean="0">
+                <a:solidFill>
+                  <a:schemeClr val="bg1"/>
+                </a:solidFill>
+              </a:rPr>
+              <a:t>  Group members name</a:t>
+            </a:r>
+          </a:p>
+          <a:p>
+            <a:pPr marL="342900" indent="-342900">
+              <a:buAutoNum type="arabicPeriod"/>
+            </a:pPr>
+            <a:r>
+              <a:rPr lang="en-US" dirty="0" smtClean="0">
+                <a:solidFill>
+                  <a:schemeClr val="bg1"/>
+                </a:solidFill>
+              </a:rPr>
+              <a:t>Bhavishya kumar</a:t>
+            </a:r>
+          </a:p>
+          <a:p>
+            <a:pPr marL="342900" indent="-342900">
+              <a:buAutoNum type="arabicPeriod" startAt="2"/>
+            </a:pPr>
+            <a:r>
+              <a:rPr lang="en-US" dirty="0" smtClean="0">
+                <a:solidFill>
+                  <a:schemeClr val="bg1"/>
+                </a:solidFill>
+              </a:rPr>
+              <a:t>Aditya Singh</a:t>
+            </a:r>
+          </a:p>
+          <a:p>
+            <a:pPr marL="342900" indent="-342900">
+              <a:buAutoNum type="arabicPeriod" startAt="3"/>
+            </a:pPr>
+            <a:r>
+              <a:rPr lang="en-US" dirty="0" smtClean="0">
+                <a:solidFill>
+                  <a:schemeClr val="bg1"/>
+                </a:solidFill>
+              </a:rPr>
+              <a:t>Atharv Pandey</a:t>
+            </a:r>
+          </a:p>
+          <a:p>
+            <a:r>
+              <a:rPr lang="en-US" dirty="0" smtClean="0">
+                <a:solidFill>
+                  <a:schemeClr val="bg1"/>
+                </a:solidFill>
+              </a:rPr>
+              <a:t>4.   Manish </a:t>
+            </a:r>
+            <a:r>
+              <a:rPr lang="en-US" dirty="0" err="1" smtClean="0">
+                <a:solidFill>
+                  <a:schemeClr val="bg1"/>
+                </a:solidFill>
+              </a:rPr>
+              <a:t>Ranjan</a:t>
+            </a:r>
+            <a:r>
+              <a:rPr lang="en-US" dirty="0" smtClean="0">
+                <a:solidFill>
+                  <a:schemeClr val="bg1"/>
+                </a:solidFill>
+              </a:rPr>
+              <a:t> </a:t>
+            </a:r>
+            <a:endParaRPr lang="en-US" dirty="0">
+              <a:solidFill>
+                <a:schemeClr val="bg1"/>
+              </a:solidFill>
+            </a:endParaRPr>
           </a:p>
         </p:txBody>
       </p:sp>

</xml_diff>

<commit_message>
Professionalize UI: Remove all emojis and symbols from dashboards, components, and backend templates for a minimalist aesthetic
</commit_message>
<xml_diff>
--- a/EcoTrack_AI_With_OOP.pptx
+++ b/EcoTrack_AI_With_OOP.pptx
@@ -8073,190 +8073,6 @@
       </p:sp>
       <p:sp>
         <p:nvSpPr>
-          <p:cNvPr id="18" name="Shape 16"/>
-          <p:cNvSpPr/>
-          <p:nvPr/>
-        </p:nvSpPr>
-        <p:spPr>
-          <a:xfrm>
-            <a:off x="457200" y="2814066"/>
-            <a:ext cx="8229600" cy="1652778"/>
-          </a:xfrm>
-          <a:prstGeom prst="rect">
-            <a:avLst/>
-          </a:prstGeom>
-          <a:gradFill rotWithShape="1">
-            <a:gsLst>
-              <a:gs pos="0">
-                <a:srgbClr val="0F2318"/>
-              </a:gs>
-              <a:gs pos="100000">
-                <a:srgbClr val="081510"/>
-              </a:gs>
-            </a:gsLst>
-            <a:lin ang="5400000" scaled="0"/>
-          </a:gradFill>
-          <a:ln w="22860">
-            <a:solidFill>
-              <a:srgbClr val="F59E0B"/>
-            </a:solidFill>
-            <a:prstDash val="solid"/>
-          </a:ln>
-          <a:effectLst>
-            <a:outerShdw blurRad="152400" dist="38100" dir="8100000" algn="bl" rotWithShape="0">
-              <a:srgbClr val="000000">
-                <a:alpha val="30000"/>
-              </a:srgbClr>
-            </a:outerShdw>
-          </a:effectLst>
-        </p:spPr>
-        <p:txBody>
-          <a:bodyPr/>
-          <a:lstStyle/>
-          <a:p>
-            <a:endParaRPr lang="en-IN" dirty="0"/>
-          </a:p>
-        </p:txBody>
-      </p:sp>
-      <p:sp>
-        <p:nvSpPr>
-          <p:cNvPr id="19" name="Shape 17"/>
-          <p:cNvSpPr/>
-          <p:nvPr/>
-        </p:nvSpPr>
-        <p:spPr>
-          <a:xfrm>
-            <a:off x="457200" y="2814066"/>
-            <a:ext cx="76200" cy="1616202"/>
-          </a:xfrm>
-          <a:prstGeom prst="rect">
-            <a:avLst/>
-          </a:prstGeom>
-          <a:solidFill>
-            <a:srgbClr val="F59E0B"/>
-          </a:solidFill>
-          <a:ln w="22860">
-            <a:solidFill>
-              <a:srgbClr val="F59E0B"/>
-            </a:solidFill>
-            <a:prstDash val="solid"/>
-          </a:ln>
-        </p:spPr>
-        <p:txBody>
-          <a:bodyPr/>
-          <a:lstStyle/>
-          <a:p>
-            <a:endParaRPr lang="en-IN"/>
-          </a:p>
-        </p:txBody>
-      </p:sp>
-      <p:sp>
-        <p:nvSpPr>
-          <p:cNvPr id="20" name="Text 18"/>
-          <p:cNvSpPr/>
-          <p:nvPr/>
-        </p:nvSpPr>
-        <p:spPr>
-          <a:xfrm>
-            <a:off x="484632" y="2814066"/>
-            <a:ext cx="2331720" cy="347472"/>
-          </a:xfrm>
-          <a:prstGeom prst="rect">
-            <a:avLst/>
-          </a:prstGeom>
-          <a:noFill/>
-          <a:ln/>
-        </p:spPr>
-        <p:txBody>
-          <a:bodyPr wrap="square" lIns="0" tIns="0" rIns="0" bIns="0" rtlCol="0" anchor="ctr"/>
-          <a:lstStyle/>
-          <a:p>
-            <a:pPr marL="0" indent="0">
-              <a:buNone/>
-            </a:pPr>
-            <a:r>
-              <a:rPr lang="en-US" sz="1300" b="1" dirty="0">
-                <a:solidFill>
-                  <a:srgbClr val="F59E0B"/>
-                </a:solidFill>
-                <a:latin typeface="Trebuchet MS" pitchFamily="34" charset="0"/>
-                <a:ea typeface="Trebuchet MS" pitchFamily="34" charset="-122"/>
-                <a:cs typeface="Trebuchet MS" pitchFamily="34" charset="-120"/>
-              </a:rPr>
-              <a:t>📱  QR Code</a:t>
-            </a:r>
-            <a:endParaRPr lang="en-US" sz="1300" dirty="0"/>
-          </a:p>
-        </p:txBody>
-      </p:sp>
-      <p:sp>
-        <p:nvSpPr>
-          <p:cNvPr id="21" name="Text 19"/>
-          <p:cNvSpPr/>
-          <p:nvPr/>
-        </p:nvSpPr>
-        <p:spPr>
-          <a:xfrm>
-            <a:off x="743709" y="3636952"/>
-            <a:ext cx="2331720" cy="347472"/>
-          </a:xfrm>
-          <a:prstGeom prst="rect">
-            <a:avLst/>
-          </a:prstGeom>
-          <a:noFill/>
-          <a:ln/>
-        </p:spPr>
-        <p:txBody>
-          <a:bodyPr wrap="square" lIns="0" tIns="0" rIns="0" bIns="0" rtlCol="0" anchor="ctr"/>
-          <a:lstStyle/>
-          <a:p>
-            <a:pPr marL="0" indent="0">
-              <a:buNone/>
-            </a:pPr>
-            <a:r>
-              <a:rPr lang="en-US" sz="2000" dirty="0">
-                <a:solidFill>
-                  <a:srgbClr val="F8FAF9"/>
-                </a:solidFill>
-                <a:latin typeface="Calibri" pitchFamily="34" charset="0"/>
-                <a:ea typeface="Calibri" pitchFamily="34" charset="-122"/>
-                <a:cs typeface="Calibri" pitchFamily="34" charset="-120"/>
-              </a:rPr>
-              <a:t>[ Scan to Demo </a:t>
-            </a:r>
-            <a:r>
-              <a:rPr lang="en-US" sz="2000" dirty="0" smtClean="0">
-                <a:solidFill>
-                  <a:srgbClr val="F8FAF9"/>
-                </a:solidFill>
-                <a:latin typeface="Calibri" pitchFamily="34" charset="0"/>
-                <a:ea typeface="Calibri" pitchFamily="34" charset="-122"/>
-                <a:cs typeface="Calibri" pitchFamily="34" charset="-120"/>
-              </a:rPr>
-              <a:t>]</a:t>
-            </a:r>
-          </a:p>
-          <a:p>
-            <a:pPr marL="0" indent="0">
-              <a:buNone/>
-            </a:pPr>
-            <a:r>
-              <a:rPr lang="en-US" sz="1200" dirty="0" smtClean="0">
-                <a:solidFill>
-                  <a:srgbClr val="F8FAF9"/>
-                </a:solidFill>
-                <a:latin typeface="Calibri" pitchFamily="34" charset="0"/>
-                <a:ea typeface="Calibri" pitchFamily="34" charset="-122"/>
-                <a:cs typeface="Calibri" pitchFamily="34" charset="-120"/>
-              </a:rPr>
-              <a:t>Use this website in desktop mode</a:t>
-            </a:r>
-            <a:endParaRPr lang="en-US" sz="1200" dirty="0"/>
-          </a:p>
-        </p:txBody>
-      </p:sp>
-      <p:sp>
-        <p:nvSpPr>
           <p:cNvPr id="22" name="Text 20"/>
           <p:cNvSpPr/>
           <p:nvPr/>
@@ -8390,43 +8206,6 @@
           </a:p>
         </p:txBody>
       </p:sp>
-      <p:pic>
-        <p:nvPicPr>
-          <p:cNvPr id="11" name="Picture 10">
-            <a:extLst>
-              <a:ext uri="{FF2B5EF4-FFF2-40B4-BE49-F238E27FC236}">
-                <a16:creationId xmlns:a16="http://schemas.microsoft.com/office/drawing/2014/main" id="{9C277989-8A8D-E992-AB96-0BE275281A86}"/>
-              </a:ext>
-            </a:extLst>
-          </p:cNvPr>
-          <p:cNvPicPr>
-            <a:picLocks noChangeAspect="1"/>
-          </p:cNvPicPr>
-          <p:nvPr/>
-        </p:nvPicPr>
-        <p:blipFill>
-          <a:blip r:embed="rId3"/>
-          <a:srcRect l="24933" t="23467" r="20667" b="25956"/>
-          <a:stretch>
-            <a:fillRect/>
-          </a:stretch>
-        </p:blipFill>
-        <p:spPr>
-          <a:xfrm>
-            <a:off x="4553709" y="2814066"/>
-            <a:ext cx="2798066" cy="1645772"/>
-          </a:xfrm>
-          <a:prstGeom prst="rect">
-            <a:avLst/>
-          </a:prstGeom>
-          <a:ln>
-            <a:noFill/>
-          </a:ln>
-          <a:effectLst>
-            <a:softEdge rad="112500"/>
-          </a:effectLst>
-        </p:spPr>
-      </p:pic>
     </p:spTree>
   </p:cSld>
   <p:clrMapOvr>

</xml_diff>